<commit_message>
refactor(presentation): remove extra photos, fix exact proportional logo scaling, use only EGATE logo on cover
</commit_message>
<xml_diff>
--- a/nullify_presentation.pptx
+++ b/nullify_presentation.pptx
@@ -853,7 +853,7 @@
           </a:p>
           <a:p>
             <a:r>
-              <a:t>Nullify is the autonomous algorithmic engine inside the gateway. It exists to reduce the threat dwell time to zero.</a:t>
+              <a:t>Nullify is the autonomous algorithmic engine inside the gateway. It exists to reduce threat dwell time to zero.</a:t>
             </a:r>
           </a:p>
           <a:p>
@@ -1128,7 +1128,7 @@
           </a:p>
           <a:p>
             <a:r>
-              <a:t>Each agent does one job perfectly, connected in a collaborative intelligence mesh.</a:t>
+              <a:t>Each agent does one job perfectly.</a:t>
             </a:r>
           </a:p>
         </p:txBody>
@@ -4576,7 +4576,7 @@
         <p:spPr>
           <a:xfrm>
             <a:off x="1005840" y="914400"/>
-            <a:ext cx="2194560" cy="822960"/>
+            <a:ext cx="2377440" cy="1005840"/>
           </a:xfrm>
           <a:prstGeom prst="roundRect">
             <a:avLst/>
@@ -4612,7 +4612,7 @@
       </p:sp>
       <p:pic>
         <p:nvPicPr>
-          <p:cNvPr id="5" name="Picture 4" descr="egate_logo_cropped.png"/>
+          <p:cNvPr id="5" name="Picture 4" descr="egate logo.png"/>
           <p:cNvPicPr>
             <a:picLocks noChangeAspect="1"/>
           </p:cNvPicPr>
@@ -4626,8 +4626,8 @@
         </p:blipFill>
         <p:spPr>
           <a:xfrm>
-            <a:off x="1097280" y="960120"/>
-            <a:ext cx="2011680" cy="1658277"/>
+            <a:off x="1603331" y="960120"/>
+            <a:ext cx="1182456" cy="914399"/>
           </a:xfrm>
           <a:prstGeom prst="rect">
             <a:avLst/>
@@ -4642,8 +4642,8 @@
         </p:nvSpPr>
         <p:spPr>
           <a:xfrm>
-            <a:off x="3337560" y="1143000"/>
-            <a:ext cx="2377440" cy="365760"/>
+            <a:off x="3566160" y="1234440"/>
+            <a:ext cx="2560320" cy="365760"/>
           </a:xfrm>
           <a:prstGeom prst="roundRect">
             <a:avLst/>
@@ -4697,8 +4697,8 @@
         </p:nvSpPr>
         <p:spPr>
           <a:xfrm>
-            <a:off x="5852160" y="1143000"/>
-            <a:ext cx="2011680" cy="365760"/>
+            <a:off x="6263640" y="1234440"/>
+            <a:ext cx="2194560" cy="365760"/>
           </a:xfrm>
           <a:prstGeom prst="roundRect">
             <a:avLst/>
@@ -4746,79 +4746,14 @@
       </p:sp>
       <p:sp>
         <p:nvSpPr>
-          <p:cNvPr id="8" name="TextBox 7"/>
-          <p:cNvSpPr txBox="1"/>
-          <p:nvPr/>
-        </p:nvSpPr>
-        <p:spPr>
-          <a:xfrm>
-            <a:off x="1005840" y="2011680"/>
-            <a:ext cx="5486400" cy="2560320"/>
-          </a:xfrm>
-          <a:prstGeom prst="rect">
-            <a:avLst/>
-          </a:prstGeom>
-          <a:noFill/>
-        </p:spPr>
-        <p:txBody>
-          <a:bodyPr wrap="square" lIns="0" tIns="0" rIns="0" bIns="0">
-            <a:spAutoFit/>
-          </a:bodyPr>
-          <a:lstStyle/>
-          <a:p>
-            <a:pPr>
-              <a:defRPr sz="5000" b="1">
-                <a:solidFill>
-                  <a:srgbClr val="FAF8F5"/>
-                </a:solidFill>
-                <a:latin typeface="Georgia"/>
-              </a:defRPr>
-            </a:pPr>
-            <a:r>
-              <a:t>See it. Trace it.</a:t>
-            </a:r>
-          </a:p>
-          <a:p>
-            <a:pPr>
-              <a:defRPr i="1" sz="5000" b="1">
-                <a:solidFill>
-                  <a:srgbClr val="10B981"/>
-                </a:solidFill>
-                <a:latin typeface="Georgia"/>
-              </a:defRPr>
-            </a:pPr>
-            <a:r>
-              <a:t>Nullify it.</a:t>
-            </a:r>
-          </a:p>
-          <a:p>
-            <a:pPr>
-              <a:spcBef>
-                <a:spcPts val="1400"/>
-              </a:spcBef>
-              <a:defRPr sz="1700">
-                <a:solidFill>
-                  <a:srgbClr val="BFB9AF"/>
-                </a:solidFill>
-                <a:latin typeface="Segoe UI"/>
-              </a:defRPr>
-            </a:pPr>
-            <a:r>
-              <a:t>Autonomous AI Threat Defense — From Detection to Immunity in Under 15 Milliseconds.</a:t>
-            </a:r>
-          </a:p>
-        </p:txBody>
-      </p:sp>
-      <p:sp>
-        <p:nvSpPr>
-          <p:cNvPr id="9" name="Rounded Rectangle 8"/>
+          <p:cNvPr id="8" name="Rounded Rectangle 7"/>
           <p:cNvSpPr/>
           <p:nvPr/>
         </p:nvSpPr>
         <p:spPr>
           <a:xfrm>
-            <a:off x="1005840" y="4846320"/>
-            <a:ext cx="1783080" cy="594360"/>
+            <a:off x="8595360" y="1234440"/>
+            <a:ext cx="2560320" cy="365760"/>
           </a:xfrm>
           <a:prstGeom prst="roundRect">
             <a:avLst/>
@@ -4853,17 +4788,78 @@
             <a:pPr algn="ctr">
               <a:defRPr sz="950" b="1">
                 <a:solidFill>
+                  <a:srgbClr val="BFB9AF"/>
+                </a:solidFill>
+                <a:latin typeface="Consolas"/>
+              </a:defRPr>
+            </a:pPr>
+            <a:r>
+              <a:t>READY FOR LIVE DEMO</a:t>
+            </a:r>
+          </a:p>
+        </p:txBody>
+      </p:sp>
+      <p:sp>
+        <p:nvSpPr>
+          <p:cNvPr id="9" name="TextBox 8"/>
+          <p:cNvSpPr txBox="1"/>
+          <p:nvPr/>
+        </p:nvSpPr>
+        <p:spPr>
+          <a:xfrm>
+            <a:off x="1005840" y="2286000"/>
+            <a:ext cx="10058400" cy="2377440"/>
+          </a:xfrm>
+          <a:prstGeom prst="rect">
+            <a:avLst/>
+          </a:prstGeom>
+          <a:noFill/>
+        </p:spPr>
+        <p:txBody>
+          <a:bodyPr wrap="square" lIns="0" tIns="0" rIns="0" bIns="0">
+            <a:spAutoFit/>
+          </a:bodyPr>
+          <a:lstStyle/>
+          <a:p>
+            <a:pPr>
+              <a:defRPr sz="5600" b="1">
+                <a:solidFill>
                   <a:srgbClr val="FAF8F5"/>
                 </a:solidFill>
-                <a:latin typeface="Consolas"/>
-              </a:defRPr>
-            </a:pPr>
-            <a:r>
-              <a:t>[ 01 // CORE ]</a:t>
-            </a:r>
-            <a:br/>
-            <a:r>
-              <a:t>15ms Native C Engine</a:t>
+                <a:latin typeface="Georgia"/>
+              </a:defRPr>
+            </a:pPr>
+            <a:r>
+              <a:t>See it. Trace it.</a:t>
+            </a:r>
+          </a:p>
+          <a:p>
+            <a:pPr>
+              <a:defRPr i="1" sz="5600" b="1">
+                <a:solidFill>
+                  <a:srgbClr val="10B981"/>
+                </a:solidFill>
+                <a:latin typeface="Georgia"/>
+              </a:defRPr>
+            </a:pPr>
+            <a:r>
+              <a:t>Nullify it.</a:t>
+            </a:r>
+          </a:p>
+          <a:p>
+            <a:pPr>
+              <a:spcBef>
+                <a:spcPts val="1400"/>
+              </a:spcBef>
+              <a:defRPr sz="1900">
+                <a:solidFill>
+                  <a:srgbClr val="BFB9AF"/>
+                </a:solidFill>
+                <a:latin typeface="Segoe UI"/>
+              </a:defRPr>
+            </a:pPr>
+            <a:r>
+              <a:t>Autonomous AI Threat Defense — From Detection to Immunity in Under 15 Milliseconds.</a:t>
             </a:r>
           </a:p>
         </p:txBody>
@@ -4876,8 +4872,8 @@
         </p:nvSpPr>
         <p:spPr>
           <a:xfrm>
-            <a:off x="2880360" y="4846320"/>
-            <a:ext cx="1783080" cy="594360"/>
+            <a:off x="1005840" y="4663440"/>
+            <a:ext cx="3291840" cy="1234440"/>
           </a:xfrm>
           <a:prstGeom prst="roundRect">
             <a:avLst/>
@@ -4906,37 +4902,75 @@
           </a:fontRef>
         </p:style>
         <p:txBody>
-          <a:bodyPr rtlCol="0" anchor="ctr" lIns="0" tIns="0" rIns="0" bIns="0"/>
-          <a:lstStyle/>
-          <a:p>
-            <a:pPr algn="ctr">
-              <a:defRPr sz="950" b="1">
+          <a:bodyPr rtlCol="0" anchor="ctr"/>
+          <a:lstStyle/>
+          <a:p>
+            <a:pPr algn="ctr"/>
+          </a:p>
+        </p:txBody>
+      </p:sp>
+      <p:sp>
+        <p:nvSpPr>
+          <p:cNvPr id="11" name="TextBox 10"/>
+          <p:cNvSpPr txBox="1"/>
+          <p:nvPr/>
+        </p:nvSpPr>
+        <p:spPr>
+          <a:xfrm>
+            <a:off x="1234440" y="4754880"/>
+            <a:ext cx="2834640" cy="1051560"/>
+          </a:xfrm>
+          <a:prstGeom prst="rect">
+            <a:avLst/>
+          </a:prstGeom>
+          <a:noFill/>
+        </p:spPr>
+        <p:txBody>
+          <a:bodyPr wrap="square" lIns="0" tIns="0" rIns="0" bIns="0">
+            <a:spAutoFit/>
+          </a:bodyPr>
+          <a:lstStyle/>
+          <a:p>
+            <a:pPr>
+              <a:defRPr sz="1450" b="1">
                 <a:solidFill>
                   <a:srgbClr val="FAF8F5"/>
                 </a:solidFill>
-                <a:latin typeface="Consolas"/>
-              </a:defRPr>
-            </a:pPr>
-            <a:r>
-              <a:t>[ 02 // MESH ]</a:t>
-            </a:r>
-            <a:br/>
-            <a:r>
-              <a:t>6 Collaborative AI Agents</a:t>
-            </a:r>
-          </a:p>
-        </p:txBody>
-      </p:sp>
-      <p:sp>
-        <p:nvSpPr>
-          <p:cNvPr id="11" name="Rounded Rectangle 10"/>
+                <a:latin typeface="Segoe UI"/>
+              </a:defRPr>
+            </a:pPr>
+            <a:r>
+              <a:t>[ 01 // SPEED ]  Sub-15ms Native C Engine</a:t>
+            </a:r>
+          </a:p>
+          <a:p>
+            <a:pPr>
+              <a:spcBef>
+                <a:spcPts val="300"/>
+              </a:spcBef>
+              <a:defRPr sz="1200">
+                <a:solidFill>
+                  <a:srgbClr val="BFB9AF"/>
+                </a:solidFill>
+                <a:latin typeface="Segoe UI"/>
+              </a:defRPr>
+            </a:pPr>
+            <a:r>
+              <a:t>C11 core analyzes binaries faster than a blink of an eye.</a:t>
+            </a:r>
+          </a:p>
+        </p:txBody>
+      </p:sp>
+      <p:sp>
+        <p:nvSpPr>
+          <p:cNvPr id="12" name="Rounded Rectangle 11"/>
           <p:cNvSpPr/>
           <p:nvPr/>
         </p:nvSpPr>
         <p:spPr>
           <a:xfrm>
-            <a:off x="4754879" y="4846320"/>
-            <a:ext cx="1783080" cy="594360"/>
+            <a:off x="4480560" y="4663440"/>
+            <a:ext cx="3291840" cy="1234440"/>
           </a:xfrm>
           <a:prstGeom prst="roundRect">
             <a:avLst/>
@@ -4965,37 +4999,75 @@
           </a:fontRef>
         </p:style>
         <p:txBody>
-          <a:bodyPr rtlCol="0" anchor="ctr" lIns="0" tIns="0" rIns="0" bIns="0"/>
-          <a:lstStyle/>
-          <a:p>
-            <a:pPr algn="ctr">
-              <a:defRPr sz="950" b="1">
+          <a:bodyPr rtlCol="0" anchor="ctr"/>
+          <a:lstStyle/>
+          <a:p>
+            <a:pPr algn="ctr"/>
+          </a:p>
+        </p:txBody>
+      </p:sp>
+      <p:sp>
+        <p:nvSpPr>
+          <p:cNvPr id="13" name="TextBox 12"/>
+          <p:cNvSpPr txBox="1"/>
+          <p:nvPr/>
+        </p:nvSpPr>
+        <p:spPr>
+          <a:xfrm>
+            <a:off x="4709160" y="4754880"/>
+            <a:ext cx="2834640" cy="1051560"/>
+          </a:xfrm>
+          <a:prstGeom prst="rect">
+            <a:avLst/>
+          </a:prstGeom>
+          <a:noFill/>
+        </p:spPr>
+        <p:txBody>
+          <a:bodyPr wrap="square" lIns="0" tIns="0" rIns="0" bIns="0">
+            <a:spAutoFit/>
+          </a:bodyPr>
+          <a:lstStyle/>
+          <a:p>
+            <a:pPr>
+              <a:defRPr sz="1450" b="1">
                 <a:solidFill>
                   <a:srgbClr val="FAF8F5"/>
                 </a:solidFill>
-                <a:latin typeface="Consolas"/>
-              </a:defRPr>
-            </a:pPr>
-            <a:r>
-              <a:t>[ 03 // YARA ]</a:t>
-            </a:r>
-            <a:br/>
-            <a:r>
-              <a:t>Instant Enterprise Rules</a:t>
-            </a:r>
-          </a:p>
-        </p:txBody>
-      </p:sp>
-      <p:sp>
-        <p:nvSpPr>
-          <p:cNvPr id="12" name="Rounded Rectangle 11"/>
+                <a:latin typeface="Segoe UI"/>
+              </a:defRPr>
+            </a:pPr>
+            <a:r>
+              <a:t>[ 02 // COGNITION ]  6 Collaborative AI Agents</a:t>
+            </a:r>
+          </a:p>
+          <a:p>
+            <a:pPr>
+              <a:spcBef>
+                <a:spcPts val="300"/>
+              </a:spcBef>
+              <a:defRPr sz="1200">
+                <a:solidFill>
+                  <a:srgbClr val="BFB9AF"/>
+                </a:solidFill>
+                <a:latin typeface="Segoe UI"/>
+              </a:defRPr>
+            </a:pPr>
+            <a:r>
+              <a:t>Specialized agents team up to inspect, explain, and defend.</a:t>
+            </a:r>
+          </a:p>
+        </p:txBody>
+      </p:sp>
+      <p:sp>
+        <p:nvSpPr>
+          <p:cNvPr id="14" name="Rounded Rectangle 13"/>
           <p:cNvSpPr/>
           <p:nvPr/>
         </p:nvSpPr>
         <p:spPr>
           <a:xfrm>
-            <a:off x="6675120" y="1005840"/>
-            <a:ext cx="4572000" cy="4526280"/>
+            <a:off x="7955279" y="4663440"/>
+            <a:ext cx="3291840" cy="1234440"/>
           </a:xfrm>
           <a:prstGeom prst="roundRect">
             <a:avLst/>
@@ -5031,33 +5103,61 @@
           </a:p>
         </p:txBody>
       </p:sp>
-      <p:pic>
-        <p:nvPicPr>
-          <p:cNvPr id="13" name="Picture 12" descr="cyber_shield_core.jpg"/>
-          <p:cNvPicPr>
-            <a:picLocks noChangeAspect="1"/>
-          </p:cNvPicPr>
-          <p:nvPr/>
-        </p:nvPicPr>
-        <p:blipFill>
-          <a:blip r:embed="rId3"/>
-          <a:stretch>
-            <a:fillRect/>
-          </a:stretch>
-        </p:blipFill>
-        <p:spPr>
-          <a:xfrm>
-            <a:off x="6766560" y="1097280"/>
-            <a:ext cx="4389120" cy="2449741"/>
+      <p:sp>
+        <p:nvSpPr>
+          <p:cNvPr id="15" name="TextBox 14"/>
+          <p:cNvSpPr txBox="1"/>
+          <p:nvPr/>
+        </p:nvSpPr>
+        <p:spPr>
+          <a:xfrm>
+            <a:off x="8183879" y="4754880"/>
+            <a:ext cx="2834640" cy="1051560"/>
           </a:xfrm>
           <a:prstGeom prst="rect">
             <a:avLst/>
           </a:prstGeom>
-        </p:spPr>
-      </p:pic>
-      <p:sp>
-        <p:nvSpPr>
-          <p:cNvPr id="14" name="Rectangle 13"/>
+          <a:noFill/>
+        </p:spPr>
+        <p:txBody>
+          <a:bodyPr wrap="square" lIns="0" tIns="0" rIns="0" bIns="0">
+            <a:spAutoFit/>
+          </a:bodyPr>
+          <a:lstStyle/>
+          <a:p>
+            <a:pPr>
+              <a:defRPr sz="1450" b="1">
+                <a:solidFill>
+                  <a:srgbClr val="FAF8F5"/>
+                </a:solidFill>
+                <a:latin typeface="Segoe UI"/>
+              </a:defRPr>
+            </a:pPr>
+            <a:r>
+              <a:t>[ 03 // DEFENSE ]  Instant Auto-YARA Immunity</a:t>
+            </a:r>
+          </a:p>
+          <a:p>
+            <a:pPr>
+              <a:spcBef>
+                <a:spcPts val="300"/>
+              </a:spcBef>
+              <a:defRPr sz="1200">
+                <a:solidFill>
+                  <a:srgbClr val="BFB9AF"/>
+                </a:solidFill>
+                <a:latin typeface="Segoe UI"/>
+              </a:defRPr>
+            </a:pPr>
+            <a:r>
+              <a:t>Writes instant defense rules to protect your whole network.</a:t>
+            </a:r>
+          </a:p>
+        </p:txBody>
+      </p:sp>
+      <p:sp>
+        <p:nvSpPr>
+          <p:cNvPr id="16" name="Rectangle 15"/>
           <p:cNvSpPr/>
           <p:nvPr/>
         </p:nvSpPr>
@@ -5100,7 +5200,7 @@
       </p:sp>
       <p:sp>
         <p:nvSpPr>
-          <p:cNvPr id="15" name="TextBox 14"/>
+          <p:cNvPr id="17" name="TextBox 16"/>
           <p:cNvSpPr txBox="1"/>
           <p:nvPr/>
         </p:nvSpPr>
@@ -5330,116 +5430,13 @@
       </p:sp>
       <p:sp>
         <p:nvSpPr>
-          <p:cNvPr id="6" name="TextBox 5"/>
-          <p:cNvSpPr txBox="1"/>
-          <p:nvPr/>
-        </p:nvSpPr>
-        <p:spPr>
-          <a:xfrm>
-            <a:off x="1097280" y="1920240"/>
-            <a:ext cx="4572000" cy="3931920"/>
-          </a:xfrm>
-          <a:prstGeom prst="rect">
-            <a:avLst/>
-          </a:prstGeom>
-          <a:noFill/>
-        </p:spPr>
-        <p:txBody>
-          <a:bodyPr wrap="square" lIns="0" tIns="0" rIns="0" bIns="0">
-            <a:spAutoFit/>
-          </a:bodyPr>
-          <a:lstStyle/>
-          <a:p>
-            <a:pPr>
-              <a:spcBef>
-                <a:spcPts val="2000"/>
-              </a:spcBef>
-              <a:defRPr sz="2000" b="1">
-                <a:solidFill>
-                  <a:srgbClr val="14110D"/>
-                </a:solidFill>
-                <a:latin typeface="Segoe UI"/>
-              </a:defRPr>
-            </a:pPr>
-            <a:r>
-              <a:t>Luxury Web Dashboard (localhost:8000)</a:t>
-            </a:r>
-          </a:p>
-          <a:p>
-            <a:pPr>
-              <a:spcBef>
-                <a:spcPts val="1000"/>
-              </a:spcBef>
-              <a:defRPr sz="1350">
-                <a:solidFill>
-                  <a:srgbClr val="555048"/>
-                </a:solidFill>
-                <a:latin typeface="Segoe UI"/>
-              </a:defRPr>
-            </a:pPr>
-            <a:r>
-              <a:t>• Drag-and-Drop Scanning: Drop any file to see real-time analysis in milliseconds.</a:t>
-            </a:r>
-          </a:p>
-          <a:p>
-            <a:pPr>
-              <a:spcBef>
-                <a:spcPts val="1000"/>
-              </a:spcBef>
-              <a:defRPr sz="1350">
-                <a:solidFill>
-                  <a:srgbClr val="555048"/>
-                </a:solidFill>
-                <a:latin typeface="Segoe UI"/>
-              </a:defRPr>
-            </a:pPr>
-            <a:r>
-              <a:t>• Live Confidence Radar: See risk percentage and threat family classification clearly.</a:t>
-            </a:r>
-          </a:p>
-          <a:p>
-            <a:pPr>
-              <a:spcBef>
-                <a:spcPts val="1000"/>
-              </a:spcBef>
-              <a:defRPr sz="1350">
-                <a:solidFill>
-                  <a:srgbClr val="555048"/>
-                </a:solidFill>
-                <a:latin typeface="Segoe UI"/>
-              </a:defRPr>
-            </a:pPr>
-            <a:r>
-              <a:t>• Built-in Demo Samples: One-click buttons to test safe trojans, ransomware, and benign files.</a:t>
-            </a:r>
-          </a:p>
-          <a:p>
-            <a:pPr>
-              <a:spcBef>
-                <a:spcPts val="1000"/>
-              </a:spcBef>
-              <a:defRPr sz="1350">
-                <a:solidFill>
-                  <a:srgbClr val="555048"/>
-                </a:solidFill>
-                <a:latin typeface="Segoe UI"/>
-              </a:defRPr>
-            </a:pPr>
-            <a:r>
-              <a:t>• 1-Click YARA Copy: Instantly copy auto-generated rules to your clipboard.</a:t>
-            </a:r>
-          </a:p>
-        </p:txBody>
-      </p:sp>
-      <p:sp>
-        <p:nvSpPr>
-          <p:cNvPr id="7" name="Rounded Rectangle 6"/>
+          <p:cNvPr id="6" name="Rounded Rectangle 5"/>
           <p:cNvSpPr/>
           <p:nvPr/>
         </p:nvSpPr>
         <p:spPr>
           <a:xfrm>
-            <a:off x="1097280" y="1920240"/>
+            <a:off x="1097280" y="1874519"/>
             <a:ext cx="2926080" cy="320040"/>
           </a:xfrm>
           <a:prstGeom prst="roundRect">
@@ -5480,6 +5477,106 @@
             </a:pPr>
             <a:r>
               <a:t>[ WEB INTERFACE ]</a:t>
+            </a:r>
+          </a:p>
+        </p:txBody>
+      </p:sp>
+      <p:sp>
+        <p:nvSpPr>
+          <p:cNvPr id="7" name="TextBox 6"/>
+          <p:cNvSpPr txBox="1"/>
+          <p:nvPr/>
+        </p:nvSpPr>
+        <p:spPr>
+          <a:xfrm>
+            <a:off x="1097280" y="2331720"/>
+            <a:ext cx="4572000" cy="3566160"/>
+          </a:xfrm>
+          <a:prstGeom prst="rect">
+            <a:avLst/>
+          </a:prstGeom>
+          <a:noFill/>
+        </p:spPr>
+        <p:txBody>
+          <a:bodyPr wrap="square" lIns="0" tIns="0" rIns="0" bIns="0">
+            <a:spAutoFit/>
+          </a:bodyPr>
+          <a:lstStyle/>
+          <a:p>
+            <a:pPr>
+              <a:defRPr sz="2000" b="1">
+                <a:solidFill>
+                  <a:srgbClr val="14110D"/>
+                </a:solidFill>
+                <a:latin typeface="Segoe UI"/>
+              </a:defRPr>
+            </a:pPr>
+            <a:r>
+              <a:t>Luxury Web Dashboard (localhost:8000)</a:t>
+            </a:r>
+          </a:p>
+          <a:p>
+            <a:pPr>
+              <a:spcBef>
+                <a:spcPts val="1000"/>
+              </a:spcBef>
+              <a:defRPr sz="1350">
+                <a:solidFill>
+                  <a:srgbClr val="555048"/>
+                </a:solidFill>
+                <a:latin typeface="Segoe UI"/>
+              </a:defRPr>
+            </a:pPr>
+            <a:r>
+              <a:t>• Drag-and-Drop Scanning: Drop any file to see real-time analysis in milliseconds.</a:t>
+            </a:r>
+          </a:p>
+          <a:p>
+            <a:pPr>
+              <a:spcBef>
+                <a:spcPts val="1000"/>
+              </a:spcBef>
+              <a:defRPr sz="1350">
+                <a:solidFill>
+                  <a:srgbClr val="555048"/>
+                </a:solidFill>
+                <a:latin typeface="Segoe UI"/>
+              </a:defRPr>
+            </a:pPr>
+            <a:r>
+              <a:t>• Live Confidence Radar: See risk percentage and threat family classification clearly.</a:t>
+            </a:r>
+          </a:p>
+          <a:p>
+            <a:pPr>
+              <a:spcBef>
+                <a:spcPts val="1000"/>
+              </a:spcBef>
+              <a:defRPr sz="1350">
+                <a:solidFill>
+                  <a:srgbClr val="555048"/>
+                </a:solidFill>
+                <a:latin typeface="Segoe UI"/>
+              </a:defRPr>
+            </a:pPr>
+            <a:r>
+              <a:t>• Built-in Demo Samples: One-click buttons to test safe trojans, ransomware, and benign files.</a:t>
+            </a:r>
+          </a:p>
+          <a:p>
+            <a:pPr>
+              <a:spcBef>
+                <a:spcPts val="1000"/>
+              </a:spcBef>
+              <a:defRPr sz="1350">
+                <a:solidFill>
+                  <a:srgbClr val="555048"/>
+                </a:solidFill>
+                <a:latin typeface="Segoe UI"/>
+              </a:defRPr>
+            </a:pPr>
+            <a:r>
+              <a:t>• 1-Click YARA Copy: Instantly copy auto-generated rules to your clipboard.</a:t>
             </a:r>
           </a:p>
         </p:txBody>
@@ -6586,7 +6683,7 @@
         <p:spPr>
           <a:xfrm>
             <a:off x="1005840" y="914400"/>
-            <a:ext cx="2194560" cy="822960"/>
+            <a:ext cx="2377440" cy="1005840"/>
           </a:xfrm>
           <a:prstGeom prst="roundRect">
             <a:avLst/>
@@ -6622,7 +6719,7 @@
       </p:sp>
       <p:pic>
         <p:nvPicPr>
-          <p:cNvPr id="5" name="Picture 4" descr="egate_logo_cropped.png"/>
+          <p:cNvPr id="5" name="Picture 4" descr="egate logo.png"/>
           <p:cNvPicPr>
             <a:picLocks noChangeAspect="1"/>
           </p:cNvPicPr>
@@ -6636,8 +6733,8 @@
         </p:blipFill>
         <p:spPr>
           <a:xfrm>
-            <a:off x="1097280" y="960120"/>
-            <a:ext cx="2011680" cy="1658277"/>
+            <a:off x="1603331" y="960120"/>
+            <a:ext cx="1182456" cy="914399"/>
           </a:xfrm>
           <a:prstGeom prst="rect">
             <a:avLst/>
@@ -6652,8 +6749,8 @@
         </p:nvSpPr>
         <p:spPr>
           <a:xfrm>
-            <a:off x="3337560" y="1143000"/>
-            <a:ext cx="2377440" cy="365760"/>
+            <a:off x="3566160" y="1234440"/>
+            <a:ext cx="2560320" cy="365760"/>
           </a:xfrm>
           <a:prstGeom prst="roundRect">
             <a:avLst/>
@@ -6707,7 +6804,7 @@
         </p:nvSpPr>
         <p:spPr>
           <a:xfrm>
-            <a:off x="5852160" y="1143000"/>
+            <a:off x="6263640" y="1234440"/>
             <a:ext cx="2194560" cy="365760"/>
           </a:xfrm>
           <a:prstGeom prst="roundRect">
@@ -6762,7 +6859,7 @@
         </p:nvSpPr>
         <p:spPr>
           <a:xfrm>
-            <a:off x="1005840" y="2011680"/>
+            <a:off x="1005840" y="2148840"/>
             <a:ext cx="10058400" cy="1645920"/>
           </a:xfrm>
           <a:prstGeom prst="rect">
@@ -7508,7 +7605,7 @@
       </p:sp>
       <p:pic>
         <p:nvPicPr>
-          <p:cNvPr id="6" name="Picture 5" descr="egate_logo.png"/>
+          <p:cNvPr id="6" name="Picture 5" descr="egate logo.png"/>
           <p:cNvPicPr>
             <a:picLocks noChangeAspect="1"/>
           </p:cNvPicPr>
@@ -7522,8 +7619,8 @@
         </p:blipFill>
         <p:spPr>
           <a:xfrm>
-            <a:off x="1188720" y="2011680"/>
-            <a:ext cx="3657600" cy="2828441"/>
+            <a:off x="1125588" y="1920240"/>
+            <a:ext cx="3783862" cy="2926080"/>
           </a:xfrm>
           <a:prstGeom prst="rect">
             <a:avLst/>
@@ -7538,7 +7635,7 @@
         </p:nvSpPr>
         <p:spPr>
           <a:xfrm>
-            <a:off x="1097280" y="5120640"/>
+            <a:off x="1097280" y="5166360"/>
             <a:ext cx="3840480" cy="731520"/>
           </a:xfrm>
           <a:prstGeom prst="rect">
@@ -9582,7 +9679,7 @@
         <p:spPr>
           <a:xfrm>
             <a:off x="822960" y="1645920"/>
-            <a:ext cx="6217920" cy="4434840"/>
+            <a:ext cx="5120640" cy="4434840"/>
           </a:xfrm>
           <a:prstGeom prst="roundRect">
             <a:avLst/>
@@ -9620,176 +9717,23 @@
       </p:sp>
       <p:sp>
         <p:nvSpPr>
-          <p:cNvPr id="6" name="TextBox 5"/>
-          <p:cNvSpPr txBox="1"/>
+          <p:cNvPr id="6" name="Rounded Rectangle 5"/>
+          <p:cNvSpPr/>
           <p:nvPr/>
         </p:nvSpPr>
         <p:spPr>
           <a:xfrm>
             <a:off x="1097280" y="1874519"/>
-            <a:ext cx="5669280" cy="4023360"/>
-          </a:xfrm>
-          <a:prstGeom prst="rect">
-            <a:avLst/>
-          </a:prstGeom>
-          <a:noFill/>
-        </p:spPr>
-        <p:txBody>
-          <a:bodyPr wrap="square" lIns="0" tIns="0" rIns="0" bIns="0">
-            <a:spAutoFit/>
-          </a:bodyPr>
-          <a:lstStyle/>
-          <a:p>
-            <a:pPr>
-              <a:spcBef>
-                <a:spcPts val="1400"/>
-              </a:spcBef>
-              <a:defRPr sz="1100" b="1">
-                <a:solidFill>
-                  <a:srgbClr val="059669"/>
-                </a:solidFill>
-                <a:latin typeface="Consolas"/>
-              </a:defRPr>
-            </a:pPr>
-            <a:r>
-              <a:t>[ STAGE 1: NATIVE C SPEED ]</a:t>
-            </a:r>
-          </a:p>
-          <a:p>
-            <a:pPr>
-              <a:spcBef>
-                <a:spcPts val="400"/>
-              </a:spcBef>
-              <a:defRPr sz="1200">
-                <a:solidFill>
-                  <a:srgbClr val="14110D"/>
-                </a:solidFill>
-                <a:latin typeface="Segoe UI"/>
-              </a:defRPr>
-            </a:pPr>
-            <a:r>
-              <a:t>• Agent 1: Triage Agent: Checks magic bytes, headers, and streams MD5/SHA-1/SHA-256 in &lt; 1ms.</a:t>
-            </a:r>
-          </a:p>
-          <a:p>
-            <a:pPr>
-              <a:spcBef>
-                <a:spcPts val="400"/>
-              </a:spcBef>
-              <a:defRPr sz="1200">
-                <a:solidFill>
-                  <a:srgbClr val="14110D"/>
-                </a:solidFill>
-                <a:latin typeface="Segoe UI"/>
-              </a:defRPr>
-            </a:pPr>
-            <a:r>
-              <a:t>• Agent 2: Static Analysis Agent: Traverses PE imports in memory, detecting dangerous APIs and backdoor keys.</a:t>
-            </a:r>
-          </a:p>
-          <a:p>
-            <a:pPr>
-              <a:spcBef>
-                <a:spcPts val="1400"/>
-              </a:spcBef>
-              <a:defRPr sz="1100" b="1">
-                <a:solidFill>
-                  <a:srgbClr val="2563EB"/>
-                </a:solidFill>
-                <a:latin typeface="Consolas"/>
-              </a:defRPr>
-            </a:pPr>
-            <a:r>
-              <a:t>[ STAGE 2: AI COGNITION &amp; DEFENSE ]</a:t>
-            </a:r>
-          </a:p>
-          <a:p>
-            <a:pPr>
-              <a:spcBef>
-                <a:spcPts val="400"/>
-              </a:spcBef>
-              <a:defRPr sz="1200">
-                <a:solidFill>
-                  <a:srgbClr val="14110D"/>
-                </a:solidFill>
-                <a:latin typeface="Segoe UI"/>
-              </a:defRPr>
-            </a:pPr>
-            <a:r>
-              <a:t>• Agent 3: Behavioral Agent: Traces process trees and correlates Sysmon JSONL logs.</a:t>
-            </a:r>
-          </a:p>
-          <a:p>
-            <a:pPr>
-              <a:spcBef>
-                <a:spcPts val="400"/>
-              </a:spcBef>
-              <a:defRPr sz="1200">
-                <a:solidFill>
-                  <a:srgbClr val="14110D"/>
-                </a:solidFill>
-                <a:latin typeface="Segoe UI"/>
-              </a:defRPr>
-            </a:pPr>
-            <a:r>
-              <a:t>• Agent 4: Classification Agent: Evaluates 2,381 features via EMBER 2017 machine learning.</a:t>
-            </a:r>
-          </a:p>
-          <a:p>
-            <a:pPr>
-              <a:spcBef>
-                <a:spcPts val="400"/>
-              </a:spcBef>
-              <a:defRPr sz="1200">
-                <a:solidFill>
-                  <a:srgbClr val="14110D"/>
-                </a:solidFill>
-                <a:latin typeface="Segoe UI"/>
-              </a:defRPr>
-            </a:pPr>
-            <a:r>
-              <a:t>• Agent 5: Reasoning Agent: Synthesizes plain-English explanations with MITRE ATT&amp;CK tags.</a:t>
-            </a:r>
-          </a:p>
-          <a:p>
-            <a:pPr>
-              <a:spcBef>
-                <a:spcPts val="400"/>
-              </a:spcBef>
-              <a:defRPr sz="1200">
-                <a:solidFill>
-                  <a:srgbClr val="14110D"/>
-                </a:solidFill>
-                <a:latin typeface="Segoe UI"/>
-              </a:defRPr>
-            </a:pPr>
-            <a:r>
-              <a:t>• Agent 6: Defense Agent: Auto-generates syntax-validated YARA rules ready for deployment.</a:t>
-            </a:r>
-          </a:p>
-        </p:txBody>
-      </p:sp>
-      <p:sp>
-        <p:nvSpPr>
-          <p:cNvPr id="7" name="Rounded Rectangle 6"/>
-          <p:cNvSpPr/>
-          <p:nvPr/>
-        </p:nvSpPr>
-        <p:spPr>
-          <a:xfrm>
-            <a:off x="7269480" y="1645920"/>
-            <a:ext cx="4096512" cy="4434840"/>
+            <a:ext cx="2926080" cy="347472"/>
           </a:xfrm>
           <a:prstGeom prst="roundRect">
             <a:avLst/>
           </a:prstGeom>
           <a:solidFill>
-            <a:srgbClr val="1F1A14"/>
+            <a:srgbClr val="ECFDF5"/>
           </a:solidFill>
-          <a:ln w="12700">
-            <a:solidFill>
-              <a:srgbClr val="322B22"/>
-            </a:solidFill>
+          <a:ln>
+            <a:noFill/>
           </a:ln>
         </p:spPr>
         <p:style>
@@ -9807,76 +9751,356 @@
           </a:fontRef>
         </p:style>
         <p:txBody>
-          <a:bodyPr rtlCol="0" anchor="ctr"/>
-          <a:lstStyle/>
-          <a:p>
-            <a:pPr algn="ctr"/>
-          </a:p>
-        </p:txBody>
-      </p:sp>
-      <p:pic>
-        <p:nvPicPr>
-          <p:cNvPr id="8" name="Picture 7" descr="neural_agent_mesh.jpg"/>
-          <p:cNvPicPr>
-            <a:picLocks noChangeAspect="1"/>
-          </p:cNvPicPr>
-          <p:nvPr/>
-        </p:nvPicPr>
-        <p:blipFill>
-          <a:blip r:embed="rId2"/>
-          <a:stretch>
-            <a:fillRect/>
-          </a:stretch>
-        </p:blipFill>
-        <p:spPr>
-          <a:xfrm>
-            <a:off x="7360920" y="1737360"/>
-            <a:ext cx="3913632" cy="2184353"/>
+          <a:bodyPr rtlCol="0" anchor="ctr" lIns="0" tIns="0" rIns="0" bIns="0"/>
+          <a:lstStyle/>
+          <a:p>
+            <a:pPr algn="ctr">
+              <a:defRPr sz="950" b="1">
+                <a:solidFill>
+                  <a:srgbClr val="059669"/>
+                </a:solidFill>
+                <a:latin typeface="Consolas"/>
+              </a:defRPr>
+            </a:pPr>
+            <a:r>
+              <a:t>[ STAGE 1: NATIVE C SPEED ]</a:t>
+            </a:r>
+          </a:p>
+        </p:txBody>
+      </p:sp>
+      <p:sp>
+        <p:nvSpPr>
+          <p:cNvPr id="7" name="TextBox 6"/>
+          <p:cNvSpPr txBox="1"/>
+          <p:nvPr/>
+        </p:nvSpPr>
+        <p:spPr>
+          <a:xfrm>
+            <a:off x="1097280" y="2377440"/>
+            <a:ext cx="4572000" cy="3474720"/>
           </a:xfrm>
           <a:prstGeom prst="rect">
             <a:avLst/>
           </a:prstGeom>
-        </p:spPr>
-      </p:pic>
-      <p:sp>
-        <p:nvSpPr>
-          <p:cNvPr id="9" name="TextBox 8"/>
-          <p:cNvSpPr txBox="1"/>
-          <p:nvPr/>
-        </p:nvSpPr>
-        <p:spPr>
-          <a:xfrm>
-            <a:off x="7452360" y="5349240"/>
-            <a:ext cx="3749039" cy="548640"/>
-          </a:xfrm>
-          <a:prstGeom prst="rect">
-            <a:avLst/>
-          </a:prstGeom>
           <a:noFill/>
         </p:spPr>
         <p:txBody>
-          <a:bodyPr wrap="none" lIns="0" tIns="0" rIns="0" bIns="0">
+          <a:bodyPr wrap="square" lIns="0" tIns="0" rIns="0" bIns="0">
             <a:spAutoFit/>
           </a:bodyPr>
           <a:lstStyle/>
           <a:p>
+            <a:pPr>
+              <a:defRPr sz="1700" b="1">
+                <a:solidFill>
+                  <a:srgbClr val="14110D"/>
+                </a:solidFill>
+                <a:latin typeface="Segoe UI"/>
+              </a:defRPr>
+            </a:pPr>
+            <a:r>
+              <a:t>Agent 1: Triage Agent</a:t>
+            </a:r>
+          </a:p>
+          <a:p>
+            <a:pPr>
+              <a:spcBef>
+                <a:spcPts val="600"/>
+              </a:spcBef>
+              <a:defRPr sz="1400">
+                <a:solidFill>
+                  <a:srgbClr val="555048"/>
+                </a:solidFill>
+                <a:latin typeface="Segoe UI"/>
+              </a:defRPr>
+            </a:pPr>
+            <a:r>
+              <a:t>Checks magic bytes, verifies PE/ELF headers, and streams MD5, SHA-1, and SHA-256 hashes in a single pass in under 1 millisecond.</a:t>
+            </a:r>
+          </a:p>
+          <a:p>
+            <a:pPr>
+              <a:spcBef>
+                <a:spcPts val="2200"/>
+              </a:spcBef>
+              <a:defRPr sz="1700" b="1">
+                <a:solidFill>
+                  <a:srgbClr val="14110D"/>
+                </a:solidFill>
+                <a:latin typeface="Segoe UI"/>
+              </a:defRPr>
+            </a:pPr>
+            <a:r>
+              <a:t>Agent 2: Static Analysis Agent</a:t>
+            </a:r>
+          </a:p>
+          <a:p>
+            <a:pPr>
+              <a:spcBef>
+                <a:spcPts val="600"/>
+              </a:spcBef>
+              <a:defRPr sz="1400">
+                <a:solidFill>
+                  <a:srgbClr val="555048"/>
+                </a:solidFill>
+                <a:latin typeface="Segoe UI"/>
+              </a:defRPr>
+            </a:pPr>
+            <a:r>
+              <a:t>Traverses Windows PE Import Directory directly in memory. Detects dangerous APIs (memory injection, keylogging) and backdoor registry keys in 0.1ms.</a:t>
+            </a:r>
+          </a:p>
+        </p:txBody>
+      </p:sp>
+      <p:sp>
+        <p:nvSpPr>
+          <p:cNvPr id="8" name="Rounded Rectangle 7"/>
+          <p:cNvSpPr/>
+          <p:nvPr/>
+        </p:nvSpPr>
+        <p:spPr>
+          <a:xfrm>
+            <a:off x="6245352" y="1645920"/>
+            <a:ext cx="5120640" cy="4434840"/>
+          </a:xfrm>
+          <a:prstGeom prst="roundRect">
+            <a:avLst/>
+          </a:prstGeom>
+          <a:solidFill>
+            <a:srgbClr val="FFFFFF"/>
+          </a:solidFill>
+          <a:ln w="12700">
+            <a:solidFill>
+              <a:srgbClr val="E2DCD2"/>
+            </a:solidFill>
+          </a:ln>
+        </p:spPr>
+        <p:style>
+          <a:lnRef idx="1">
+            <a:schemeClr val="accent1"/>
+          </a:lnRef>
+          <a:fillRef idx="3">
+            <a:schemeClr val="accent1"/>
+          </a:fillRef>
+          <a:effectRef idx="2">
+            <a:schemeClr val="accent1"/>
+          </a:effectRef>
+          <a:fontRef idx="minor">
+            <a:schemeClr val="lt1"/>
+          </a:fontRef>
+        </p:style>
+        <p:txBody>
+          <a:bodyPr rtlCol="0" anchor="ctr"/>
+          <a:lstStyle/>
+          <a:p>
+            <a:pPr algn="ctr"/>
+          </a:p>
+        </p:txBody>
+      </p:sp>
+      <p:sp>
+        <p:nvSpPr>
+          <p:cNvPr id="9" name="Rounded Rectangle 8"/>
+          <p:cNvSpPr/>
+          <p:nvPr/>
+        </p:nvSpPr>
+        <p:spPr>
+          <a:xfrm>
+            <a:off x="6519672" y="1874519"/>
+            <a:ext cx="3108960" cy="347472"/>
+          </a:xfrm>
+          <a:prstGeom prst="roundRect">
+            <a:avLst/>
+          </a:prstGeom>
+          <a:solidFill>
+            <a:srgbClr val="EFF6FF"/>
+          </a:solidFill>
+          <a:ln>
+            <a:noFill/>
+          </a:ln>
+        </p:spPr>
+        <p:style>
+          <a:lnRef idx="1">
+            <a:schemeClr val="accent1"/>
+          </a:lnRef>
+          <a:fillRef idx="3">
+            <a:schemeClr val="accent1"/>
+          </a:fillRef>
+          <a:effectRef idx="2">
+            <a:schemeClr val="accent1"/>
+          </a:effectRef>
+          <a:fontRef idx="minor">
+            <a:schemeClr val="lt1"/>
+          </a:fontRef>
+        </p:style>
+        <p:txBody>
+          <a:bodyPr rtlCol="0" anchor="ctr" lIns="0" tIns="0" rIns="0" bIns="0"/>
+          <a:lstStyle/>
+          <a:p>
             <a:pPr algn="ctr">
-              <a:defRPr sz="1000" b="1">
-                <a:solidFill>
-                  <a:srgbClr val="10B981"/>
+              <a:defRPr sz="950" b="1">
+                <a:solidFill>
+                  <a:srgbClr val="2563EB"/>
                 </a:solidFill>
                 <a:latin typeface="Consolas"/>
               </a:defRPr>
             </a:pPr>
             <a:r>
-              <a:t>COLLABORATIVE AGENT LATTICE</a:t>
-            </a:r>
-          </a:p>
-        </p:txBody>
-      </p:sp>
-      <p:sp>
-        <p:nvSpPr>
-          <p:cNvPr id="10" name="Rectangle 9"/>
+              <a:t>[ STAGE 2: AI COGNITION &amp; DEFENSE ]</a:t>
+            </a:r>
+          </a:p>
+        </p:txBody>
+      </p:sp>
+      <p:sp>
+        <p:nvSpPr>
+          <p:cNvPr id="10" name="TextBox 9"/>
+          <p:cNvSpPr txBox="1"/>
+          <p:nvPr/>
+        </p:nvSpPr>
+        <p:spPr>
+          <a:xfrm>
+            <a:off x="6519672" y="2377440"/>
+            <a:ext cx="4572000" cy="3474720"/>
+          </a:xfrm>
+          <a:prstGeom prst="rect">
+            <a:avLst/>
+          </a:prstGeom>
+          <a:noFill/>
+        </p:spPr>
+        <p:txBody>
+          <a:bodyPr wrap="square" lIns="0" tIns="0" rIns="0" bIns="0">
+            <a:spAutoFit/>
+          </a:bodyPr>
+          <a:lstStyle/>
+          <a:p>
+            <a:pPr>
+              <a:defRPr sz="1550" b="1">
+                <a:solidFill>
+                  <a:srgbClr val="14110D"/>
+                </a:solidFill>
+                <a:latin typeface="Segoe UI"/>
+              </a:defRPr>
+            </a:pPr>
+            <a:r>
+              <a:t>Agent 3: Behavioral Agent</a:t>
+            </a:r>
+          </a:p>
+          <a:p>
+            <a:pPr>
+              <a:spcBef>
+                <a:spcPts val="300"/>
+              </a:spcBef>
+              <a:defRPr sz="1300">
+                <a:solidFill>
+                  <a:srgbClr val="555048"/>
+                </a:solidFill>
+                <a:latin typeface="Segoe UI"/>
+              </a:defRPr>
+            </a:pPr>
+            <a:r>
+              <a:t>Traces process execution trees and correlates Windows Sysmon logs.</a:t>
+            </a:r>
+          </a:p>
+          <a:p>
+            <a:pPr>
+              <a:spcBef>
+                <a:spcPts val="1000"/>
+              </a:spcBef>
+              <a:defRPr sz="1550" b="1">
+                <a:solidFill>
+                  <a:srgbClr val="14110D"/>
+                </a:solidFill>
+                <a:latin typeface="Segoe UI"/>
+              </a:defRPr>
+            </a:pPr>
+            <a:r>
+              <a:t>Agent 4: Classification Agent</a:t>
+            </a:r>
+          </a:p>
+          <a:p>
+            <a:pPr>
+              <a:spcBef>
+                <a:spcPts val="300"/>
+              </a:spcBef>
+              <a:defRPr sz="1300">
+                <a:solidFill>
+                  <a:srgbClr val="555048"/>
+                </a:solidFill>
+                <a:latin typeface="Segoe UI"/>
+              </a:defRPr>
+            </a:pPr>
+            <a:r>
+              <a:t>Scores 2,381 features using an ML model trained on 1.1 million binaries.</a:t>
+            </a:r>
+          </a:p>
+          <a:p>
+            <a:pPr>
+              <a:spcBef>
+                <a:spcPts val="1000"/>
+              </a:spcBef>
+              <a:defRPr sz="1550" b="1">
+                <a:solidFill>
+                  <a:srgbClr val="14110D"/>
+                </a:solidFill>
+                <a:latin typeface="Segoe UI"/>
+              </a:defRPr>
+            </a:pPr>
+            <a:r>
+              <a:t>Agent 5: Reasoning Agent</a:t>
+            </a:r>
+          </a:p>
+          <a:p>
+            <a:pPr>
+              <a:spcBef>
+                <a:spcPts val="300"/>
+              </a:spcBef>
+              <a:defRPr sz="1300">
+                <a:solidFill>
+                  <a:srgbClr val="555048"/>
+                </a:solidFill>
+                <a:latin typeface="Segoe UI"/>
+              </a:defRPr>
+            </a:pPr>
+            <a:r>
+              <a:t>Explains *why* the file is malicious in plain English for security analysts.</a:t>
+            </a:r>
+          </a:p>
+          <a:p>
+            <a:pPr>
+              <a:spcBef>
+                <a:spcPts val="1000"/>
+              </a:spcBef>
+              <a:defRPr sz="1550" b="1">
+                <a:solidFill>
+                  <a:srgbClr val="14110D"/>
+                </a:solidFill>
+                <a:latin typeface="Segoe UI"/>
+              </a:defRPr>
+            </a:pPr>
+            <a:r>
+              <a:t>Agent 6: Defense Agent</a:t>
+            </a:r>
+          </a:p>
+          <a:p>
+            <a:pPr>
+              <a:spcBef>
+                <a:spcPts val="300"/>
+              </a:spcBef>
+              <a:defRPr sz="1300">
+                <a:solidFill>
+                  <a:srgbClr val="555048"/>
+                </a:solidFill>
+                <a:latin typeface="Segoe UI"/>
+              </a:defRPr>
+            </a:pPr>
+            <a:r>
+              <a:t>Automatically writes a clean, syntax-validated YARA rule to block it.</a:t>
+            </a:r>
+          </a:p>
+        </p:txBody>
+      </p:sp>
+      <p:sp>
+        <p:nvSpPr>
+          <p:cNvPr id="11" name="Rectangle 10"/>
           <p:cNvSpPr/>
           <p:nvPr/>
         </p:nvSpPr>
@@ -9919,7 +10143,7 @@
       </p:sp>
       <p:sp>
         <p:nvSpPr>
-          <p:cNvPr id="11" name="TextBox 10"/>
+          <p:cNvPr id="12" name="TextBox 11"/>
           <p:cNvSpPr txBox="1"/>
           <p:nvPr/>
         </p:nvSpPr>
@@ -10149,94 +10373,7 @@
       </p:sp>
       <p:sp>
         <p:nvSpPr>
-          <p:cNvPr id="6" name="TextBox 5"/>
-          <p:cNvSpPr txBox="1"/>
-          <p:nvPr/>
-        </p:nvSpPr>
-        <p:spPr>
-          <a:xfrm>
-            <a:off x="1097280" y="1828800"/>
-            <a:ext cx="2834640" cy="3291840"/>
-          </a:xfrm>
-          <a:prstGeom prst="rect">
-            <a:avLst/>
-          </a:prstGeom>
-          <a:noFill/>
-        </p:spPr>
-        <p:txBody>
-          <a:bodyPr wrap="square" lIns="0" tIns="0" rIns="0" bIns="0">
-            <a:spAutoFit/>
-          </a:bodyPr>
-          <a:lstStyle/>
-          <a:p>
-            <a:pPr>
-              <a:spcBef>
-                <a:spcPts val="1800"/>
-              </a:spcBef>
-              <a:defRPr sz="3800" b="1">
-                <a:solidFill>
-                  <a:srgbClr val="059669"/>
-                </a:solidFill>
-                <a:latin typeface="Georgia"/>
-              </a:defRPr>
-            </a:pPr>
-            <a:r>
-              <a:t>500x Faster</a:t>
-            </a:r>
-          </a:p>
-          <a:p>
-            <a:pPr>
-              <a:spcBef>
-                <a:spcPts val="400"/>
-              </a:spcBef>
-              <a:defRPr sz="1800" b="1">
-                <a:solidFill>
-                  <a:srgbClr val="14110D"/>
-                </a:solidFill>
-                <a:latin typeface="Segoe UI"/>
-              </a:defRPr>
-            </a:pPr>
-            <a:r>
-              <a:t>PE Import Parsing</a:t>
-            </a:r>
-          </a:p>
-          <a:p>
-            <a:pPr>
-              <a:spcBef>
-                <a:spcPts val="600"/>
-              </a:spcBef>
-              <a:defRPr sz="1100" b="1">
-                <a:solidFill>
-                  <a:srgbClr val="059669"/>
-                </a:solidFill>
-                <a:latin typeface="Consolas"/>
-              </a:defRPr>
-            </a:pPr>
-            <a:r>
-              <a:t>Python: 50.0 ms  →  C: 0.1 ms</a:t>
-            </a:r>
-          </a:p>
-          <a:p>
-            <a:pPr>
-              <a:spcBef>
-                <a:spcPts val="800"/>
-              </a:spcBef>
-              <a:defRPr sz="1300">
-                <a:solidFill>
-                  <a:srgbClr val="555048"/>
-                </a:solidFill>
-                <a:latin typeface="Segoe UI"/>
-              </a:defRPr>
-            </a:pPr>
-            <a:r>
-              <a:t>Reads executable import tables directly in memory without slow Python libraries.</a:t>
-            </a:r>
-          </a:p>
-        </p:txBody>
-      </p:sp>
-      <p:sp>
-        <p:nvSpPr>
-          <p:cNvPr id="7" name="Rounded Rectangle 6"/>
+          <p:cNvPr id="6" name="Rounded Rectangle 5"/>
           <p:cNvSpPr/>
           <p:nvPr/>
         </p:nvSpPr>
@@ -10283,6 +10420,90 @@
             </a:pPr>
             <a:r>
               <a:t>[ ENGINE // 01 ]</a:t>
+            </a:r>
+          </a:p>
+        </p:txBody>
+      </p:sp>
+      <p:sp>
+        <p:nvSpPr>
+          <p:cNvPr id="7" name="TextBox 6"/>
+          <p:cNvSpPr txBox="1"/>
+          <p:nvPr/>
+        </p:nvSpPr>
+        <p:spPr>
+          <a:xfrm>
+            <a:off x="1097280" y="2194560"/>
+            <a:ext cx="2834640" cy="2926080"/>
+          </a:xfrm>
+          <a:prstGeom prst="rect">
+            <a:avLst/>
+          </a:prstGeom>
+          <a:noFill/>
+        </p:spPr>
+        <p:txBody>
+          <a:bodyPr wrap="square" lIns="0" tIns="0" rIns="0" bIns="0">
+            <a:spAutoFit/>
+          </a:bodyPr>
+          <a:lstStyle/>
+          <a:p>
+            <a:pPr>
+              <a:defRPr sz="3800" b="1">
+                <a:solidFill>
+                  <a:srgbClr val="059669"/>
+                </a:solidFill>
+                <a:latin typeface="Georgia"/>
+              </a:defRPr>
+            </a:pPr>
+            <a:r>
+              <a:t>500x Faster</a:t>
+            </a:r>
+          </a:p>
+          <a:p>
+            <a:pPr>
+              <a:spcBef>
+                <a:spcPts val="400"/>
+              </a:spcBef>
+              <a:defRPr sz="1800" b="1">
+                <a:solidFill>
+                  <a:srgbClr val="14110D"/>
+                </a:solidFill>
+                <a:latin typeface="Segoe UI"/>
+              </a:defRPr>
+            </a:pPr>
+            <a:r>
+              <a:t>PE Import Parsing</a:t>
+            </a:r>
+          </a:p>
+          <a:p>
+            <a:pPr>
+              <a:spcBef>
+                <a:spcPts val="600"/>
+              </a:spcBef>
+              <a:defRPr sz="1100" b="1">
+                <a:solidFill>
+                  <a:srgbClr val="059669"/>
+                </a:solidFill>
+                <a:latin typeface="Consolas"/>
+              </a:defRPr>
+            </a:pPr>
+            <a:r>
+              <a:t>Python: 50.0 ms  →  C: 0.1 ms</a:t>
+            </a:r>
+          </a:p>
+          <a:p>
+            <a:pPr>
+              <a:spcBef>
+                <a:spcPts val="800"/>
+              </a:spcBef>
+              <a:defRPr sz="1300">
+                <a:solidFill>
+                  <a:srgbClr val="555048"/>
+                </a:solidFill>
+                <a:latin typeface="Segoe UI"/>
+              </a:defRPr>
+            </a:pPr>
+            <a:r>
+              <a:t>Reads executable import tables directly in memory without slow Python libraries.</a:t>
             </a:r>
           </a:p>
         </p:txBody>
@@ -10334,94 +10555,7 @@
       </p:sp>
       <p:sp>
         <p:nvSpPr>
-          <p:cNvPr id="9" name="TextBox 8"/>
-          <p:cNvSpPr txBox="1"/>
-          <p:nvPr/>
-        </p:nvSpPr>
-        <p:spPr>
-          <a:xfrm>
-            <a:off x="4709160" y="1828800"/>
-            <a:ext cx="2834640" cy="3291840"/>
-          </a:xfrm>
-          <a:prstGeom prst="rect">
-            <a:avLst/>
-          </a:prstGeom>
-          <a:noFill/>
-        </p:spPr>
-        <p:txBody>
-          <a:bodyPr wrap="square" lIns="0" tIns="0" rIns="0" bIns="0">
-            <a:spAutoFit/>
-          </a:bodyPr>
-          <a:lstStyle/>
-          <a:p>
-            <a:pPr>
-              <a:spcBef>
-                <a:spcPts val="1800"/>
-              </a:spcBef>
-              <a:defRPr sz="3800" b="1">
-                <a:solidFill>
-                  <a:srgbClr val="2563EB"/>
-                </a:solidFill>
-                <a:latin typeface="Georgia"/>
-              </a:defRPr>
-            </a:pPr>
-            <a:r>
-              <a:t>18x Faster</a:t>
-            </a:r>
-          </a:p>
-          <a:p>
-            <a:pPr>
-              <a:spcBef>
-                <a:spcPts val="400"/>
-              </a:spcBef>
-              <a:defRPr sz="1800" b="1">
-                <a:solidFill>
-                  <a:srgbClr val="14110D"/>
-                </a:solidFill>
-                <a:latin typeface="Segoe UI"/>
-              </a:defRPr>
-            </a:pPr>
-            <a:r>
-              <a:t>Pattern Scanner</a:t>
-            </a:r>
-          </a:p>
-          <a:p>
-            <a:pPr>
-              <a:spcBef>
-                <a:spcPts val="600"/>
-              </a:spcBef>
-              <a:defRPr sz="1100" b="1">
-                <a:solidFill>
-                  <a:srgbClr val="2563EB"/>
-                </a:solidFill>
-                <a:latin typeface="Consolas"/>
-              </a:defRPr>
-            </a:pPr>
-            <a:r>
-              <a:t>Python: 15.4 ms  →  C: 0.8 ms</a:t>
-            </a:r>
-          </a:p>
-          <a:p>
-            <a:pPr>
-              <a:spcBef>
-                <a:spcPts val="800"/>
-              </a:spcBef>
-              <a:defRPr sz="1300">
-                <a:solidFill>
-                  <a:srgbClr val="555048"/>
-                </a:solidFill>
-                <a:latin typeface="Segoe UI"/>
-              </a:defRPr>
-            </a:pPr>
-            <a:r>
-              <a:t>Finds hidden registry keys, download cradles, and backdoor strings in a single pass.</a:t>
-            </a:r>
-          </a:p>
-        </p:txBody>
-      </p:sp>
-      <p:sp>
-        <p:nvSpPr>
-          <p:cNvPr id="10" name="Rounded Rectangle 9"/>
+          <p:cNvPr id="9" name="Rounded Rectangle 8"/>
           <p:cNvSpPr/>
           <p:nvPr/>
         </p:nvSpPr>
@@ -10468,6 +10602,90 @@
             </a:pPr>
             <a:r>
               <a:t>[ ENGINE // 02 ]</a:t>
+            </a:r>
+          </a:p>
+        </p:txBody>
+      </p:sp>
+      <p:sp>
+        <p:nvSpPr>
+          <p:cNvPr id="10" name="TextBox 9"/>
+          <p:cNvSpPr txBox="1"/>
+          <p:nvPr/>
+        </p:nvSpPr>
+        <p:spPr>
+          <a:xfrm>
+            <a:off x="4709160" y="2194560"/>
+            <a:ext cx="2834640" cy="2926080"/>
+          </a:xfrm>
+          <a:prstGeom prst="rect">
+            <a:avLst/>
+          </a:prstGeom>
+          <a:noFill/>
+        </p:spPr>
+        <p:txBody>
+          <a:bodyPr wrap="square" lIns="0" tIns="0" rIns="0" bIns="0">
+            <a:spAutoFit/>
+          </a:bodyPr>
+          <a:lstStyle/>
+          <a:p>
+            <a:pPr>
+              <a:defRPr sz="3800" b="1">
+                <a:solidFill>
+                  <a:srgbClr val="2563EB"/>
+                </a:solidFill>
+                <a:latin typeface="Georgia"/>
+              </a:defRPr>
+            </a:pPr>
+            <a:r>
+              <a:t>18x Faster</a:t>
+            </a:r>
+          </a:p>
+          <a:p>
+            <a:pPr>
+              <a:spcBef>
+                <a:spcPts val="400"/>
+              </a:spcBef>
+              <a:defRPr sz="1800" b="1">
+                <a:solidFill>
+                  <a:srgbClr val="14110D"/>
+                </a:solidFill>
+                <a:latin typeface="Segoe UI"/>
+              </a:defRPr>
+            </a:pPr>
+            <a:r>
+              <a:t>Pattern Scanner</a:t>
+            </a:r>
+          </a:p>
+          <a:p>
+            <a:pPr>
+              <a:spcBef>
+                <a:spcPts val="600"/>
+              </a:spcBef>
+              <a:defRPr sz="1100" b="1">
+                <a:solidFill>
+                  <a:srgbClr val="2563EB"/>
+                </a:solidFill>
+                <a:latin typeface="Consolas"/>
+              </a:defRPr>
+            </a:pPr>
+            <a:r>
+              <a:t>Python: 15.4 ms  →  C: 0.8 ms</a:t>
+            </a:r>
+          </a:p>
+          <a:p>
+            <a:pPr>
+              <a:spcBef>
+                <a:spcPts val="800"/>
+              </a:spcBef>
+              <a:defRPr sz="1300">
+                <a:solidFill>
+                  <a:srgbClr val="555048"/>
+                </a:solidFill>
+                <a:latin typeface="Segoe UI"/>
+              </a:defRPr>
+            </a:pPr>
+            <a:r>
+              <a:t>Finds hidden registry keys, download cradles, and backdoor strings in a single pass.</a:t>
             </a:r>
           </a:p>
         </p:txBody>
@@ -10519,94 +10737,7 @@
       </p:sp>
       <p:sp>
         <p:nvSpPr>
-          <p:cNvPr id="12" name="TextBox 11"/>
-          <p:cNvSpPr txBox="1"/>
-          <p:nvPr/>
-        </p:nvSpPr>
-        <p:spPr>
-          <a:xfrm>
-            <a:off x="8321040" y="1828800"/>
-            <a:ext cx="2834640" cy="3291840"/>
-          </a:xfrm>
-          <a:prstGeom prst="rect">
-            <a:avLst/>
-          </a:prstGeom>
-          <a:noFill/>
-        </p:spPr>
-        <p:txBody>
-          <a:bodyPr wrap="square" lIns="0" tIns="0" rIns="0" bIns="0">
-            <a:spAutoFit/>
-          </a:bodyPr>
-          <a:lstStyle/>
-          <a:p>
-            <a:pPr>
-              <a:spcBef>
-                <a:spcPts val="1800"/>
-              </a:spcBef>
-              <a:defRPr sz="3800" b="1">
-                <a:solidFill>
-                  <a:srgbClr val="D97706"/>
-                </a:solidFill>
-                <a:latin typeface="Georgia"/>
-              </a:defRPr>
-            </a:pPr>
-            <a:r>
-              <a:t>8x Faster</a:t>
-            </a:r>
-          </a:p>
-          <a:p>
-            <a:pPr>
-              <a:spcBef>
-                <a:spcPts val="400"/>
-              </a:spcBef>
-              <a:defRPr sz="1800" b="1">
-                <a:solidFill>
-                  <a:srgbClr val="14110D"/>
-                </a:solidFill>
-                <a:latin typeface="Segoe UI"/>
-              </a:defRPr>
-            </a:pPr>
-            <a:r>
-              <a:t>File Multi-Hashing</a:t>
-            </a:r>
-          </a:p>
-          <a:p>
-            <a:pPr>
-              <a:spcBef>
-                <a:spcPts val="600"/>
-              </a:spcBef>
-              <a:defRPr sz="1100" b="1">
-                <a:solidFill>
-                  <a:srgbClr val="D97706"/>
-                </a:solidFill>
-                <a:latin typeface="Consolas"/>
-              </a:defRPr>
-            </a:pPr>
-            <a:r>
-              <a:t>Python: 8.9 ms  →  C: 1.1 ms</a:t>
-            </a:r>
-          </a:p>
-          <a:p>
-            <a:pPr>
-              <a:spcBef>
-                <a:spcPts val="800"/>
-              </a:spcBef>
-              <a:defRPr sz="1300">
-                <a:solidFill>
-                  <a:srgbClr val="555048"/>
-                </a:solidFill>
-                <a:latin typeface="Segoe UI"/>
-              </a:defRPr>
-            </a:pPr>
-            <a:r>
-              <a:t>Streams 64KB blocks, updating MD5, SHA-1, and SHA-256 at the exact same time.</a:t>
-            </a:r>
-          </a:p>
-        </p:txBody>
-      </p:sp>
-      <p:sp>
-        <p:nvSpPr>
-          <p:cNvPr id="13" name="Rounded Rectangle 12"/>
+          <p:cNvPr id="12" name="Rounded Rectangle 11"/>
           <p:cNvSpPr/>
           <p:nvPr/>
         </p:nvSpPr>
@@ -10653,6 +10784,90 @@
             </a:pPr>
             <a:r>
               <a:t>[ ENGINE // 03 ]</a:t>
+            </a:r>
+          </a:p>
+        </p:txBody>
+      </p:sp>
+      <p:sp>
+        <p:nvSpPr>
+          <p:cNvPr id="13" name="TextBox 12"/>
+          <p:cNvSpPr txBox="1"/>
+          <p:nvPr/>
+        </p:nvSpPr>
+        <p:spPr>
+          <a:xfrm>
+            <a:off x="8321040" y="2194560"/>
+            <a:ext cx="2834640" cy="2926080"/>
+          </a:xfrm>
+          <a:prstGeom prst="rect">
+            <a:avLst/>
+          </a:prstGeom>
+          <a:noFill/>
+        </p:spPr>
+        <p:txBody>
+          <a:bodyPr wrap="square" lIns="0" tIns="0" rIns="0" bIns="0">
+            <a:spAutoFit/>
+          </a:bodyPr>
+          <a:lstStyle/>
+          <a:p>
+            <a:pPr>
+              <a:defRPr sz="3800" b="1">
+                <a:solidFill>
+                  <a:srgbClr val="D97706"/>
+                </a:solidFill>
+                <a:latin typeface="Georgia"/>
+              </a:defRPr>
+            </a:pPr>
+            <a:r>
+              <a:t>8x Faster</a:t>
+            </a:r>
+          </a:p>
+          <a:p>
+            <a:pPr>
+              <a:spcBef>
+                <a:spcPts val="400"/>
+              </a:spcBef>
+              <a:defRPr sz="1800" b="1">
+                <a:solidFill>
+                  <a:srgbClr val="14110D"/>
+                </a:solidFill>
+                <a:latin typeface="Segoe UI"/>
+              </a:defRPr>
+            </a:pPr>
+            <a:r>
+              <a:t>File Multi-Hashing</a:t>
+            </a:r>
+          </a:p>
+          <a:p>
+            <a:pPr>
+              <a:spcBef>
+                <a:spcPts val="600"/>
+              </a:spcBef>
+              <a:defRPr sz="1100" b="1">
+                <a:solidFill>
+                  <a:srgbClr val="D97706"/>
+                </a:solidFill>
+                <a:latin typeface="Consolas"/>
+              </a:defRPr>
+            </a:pPr>
+            <a:r>
+              <a:t>Python: 8.9 ms  →  C: 1.1 ms</a:t>
+            </a:r>
+          </a:p>
+          <a:p>
+            <a:pPr>
+              <a:spcBef>
+                <a:spcPts val="800"/>
+              </a:spcBef>
+              <a:defRPr sz="1300">
+                <a:solidFill>
+                  <a:srgbClr val="555048"/>
+                </a:solidFill>
+                <a:latin typeface="Segoe UI"/>
+              </a:defRPr>
+            </a:pPr>
+            <a:r>
+              <a:t>Streams 64KB blocks, updating MD5, SHA-1, and SHA-256 at the exact same time.</a:t>
             </a:r>
           </a:p>
         </p:txBody>
@@ -11698,148 +11913,13 @@
       </p:sp>
       <p:sp>
         <p:nvSpPr>
-          <p:cNvPr id="6" name="TextBox 5"/>
-          <p:cNvSpPr txBox="1"/>
-          <p:nvPr/>
-        </p:nvSpPr>
-        <p:spPr>
-          <a:xfrm>
-            <a:off x="1097280" y="1920240"/>
-            <a:ext cx="4572000" cy="3931920"/>
-          </a:xfrm>
-          <a:prstGeom prst="rect">
-            <a:avLst/>
-          </a:prstGeom>
-          <a:noFill/>
-        </p:spPr>
-        <p:txBody>
-          <a:bodyPr wrap="square" lIns="0" tIns="0" rIns="0" bIns="0">
-            <a:spAutoFit/>
-          </a:bodyPr>
-          <a:lstStyle/>
-          <a:p>
-            <a:pPr>
-              <a:spcBef>
-                <a:spcPts val="2200"/>
-              </a:spcBef>
-              <a:defRPr sz="2000" b="1">
-                <a:solidFill>
-                  <a:srgbClr val="14110D"/>
-                </a:solidFill>
-                <a:latin typeface="Segoe UI"/>
-              </a:defRPr>
-            </a:pPr>
-            <a:r>
-              <a:t>Tells You What Happened &amp; Blocks It Everywhere</a:t>
-            </a:r>
-          </a:p>
-          <a:p>
-            <a:pPr>
-              <a:spcBef>
-                <a:spcPts val="1200"/>
-              </a:spcBef>
-              <a:defRPr sz="1500" b="1">
-                <a:solidFill>
-                  <a:srgbClr val="14110D"/>
-                </a:solidFill>
-                <a:latin typeface="Segoe UI"/>
-              </a:defRPr>
-            </a:pPr>
-            <a:r>
-              <a:t>• Explains the Threat Clearly:</a:t>
-            </a:r>
-          </a:p>
-          <a:p>
-            <a:pPr>
-              <a:spcBef>
-                <a:spcPts val="200"/>
-              </a:spcBef>
-              <a:defRPr sz="1300">
-                <a:solidFill>
-                  <a:srgbClr val="555048"/>
-                </a:solidFill>
-                <a:latin typeface="Segoe UI"/>
-              </a:defRPr>
-            </a:pPr>
-            <a:r>
-              <a:t>Identifies the exact techniques the attacker used (e.g. injecting code into processes or setting up secret auto-run keys).</a:t>
-            </a:r>
-          </a:p>
-          <a:p>
-            <a:pPr>
-              <a:spcBef>
-                <a:spcPts val="1200"/>
-              </a:spcBef>
-              <a:defRPr sz="1500" b="1">
-                <a:solidFill>
-                  <a:srgbClr val="14110D"/>
-                </a:solidFill>
-                <a:latin typeface="Segoe UI"/>
-              </a:defRPr>
-            </a:pPr>
-            <a:r>
-              <a:t>• Maps to MITRE ATT&amp;CK:</a:t>
-            </a:r>
-          </a:p>
-          <a:p>
-            <a:pPr>
-              <a:spcBef>
-                <a:spcPts val="200"/>
-              </a:spcBef>
-              <a:defRPr sz="1300">
-                <a:solidFill>
-                  <a:srgbClr val="555048"/>
-                </a:solidFill>
-                <a:latin typeface="Segoe UI"/>
-              </a:defRPr>
-            </a:pPr>
-            <a:r>
-              <a:t>Industry-standard tagging (T1055, T1547) so security teams understand the risk instantly.</a:t>
-            </a:r>
-          </a:p>
-          <a:p>
-            <a:pPr>
-              <a:spcBef>
-                <a:spcPts val="1200"/>
-              </a:spcBef>
-              <a:defRPr sz="1500" b="1">
-                <a:solidFill>
-                  <a:srgbClr val="14110D"/>
-                </a:solidFill>
-                <a:latin typeface="Segoe UI"/>
-              </a:defRPr>
-            </a:pPr>
-            <a:r>
-              <a:t>• Writes the Defense Rule:</a:t>
-            </a:r>
-          </a:p>
-          <a:p>
-            <a:pPr>
-              <a:spcBef>
-                <a:spcPts val="200"/>
-              </a:spcBef>
-              <a:defRPr sz="1300">
-                <a:solidFill>
-                  <a:srgbClr val="555048"/>
-                </a:solidFill>
-                <a:latin typeface="Segoe UI"/>
-              </a:defRPr>
-            </a:pPr>
-            <a:r>
-              <a:t>Generates a complete, ready-to-use YARA rule that your firewalls, EDR, and mail filters can apply right away.</a:t>
-            </a:r>
-          </a:p>
-        </p:txBody>
-      </p:sp>
-      <p:sp>
-        <p:nvSpPr>
-          <p:cNvPr id="7" name="Rounded Rectangle 6"/>
+          <p:cNvPr id="6" name="Rounded Rectangle 5"/>
           <p:cNvSpPr/>
           <p:nvPr/>
         </p:nvSpPr>
         <p:spPr>
           <a:xfrm>
-            <a:off x="1097280" y="1920240"/>
+            <a:off x="1097280" y="1874519"/>
             <a:ext cx="3108960" cy="320040"/>
           </a:xfrm>
           <a:prstGeom prst="roundRect">
@@ -11880,6 +11960,138 @@
             </a:pPr>
             <a:r>
               <a:t>[ AUTOMATED IMMUNITY ]</a:t>
+            </a:r>
+          </a:p>
+        </p:txBody>
+      </p:sp>
+      <p:sp>
+        <p:nvSpPr>
+          <p:cNvPr id="7" name="TextBox 6"/>
+          <p:cNvSpPr txBox="1"/>
+          <p:nvPr/>
+        </p:nvSpPr>
+        <p:spPr>
+          <a:xfrm>
+            <a:off x="1097280" y="2331720"/>
+            <a:ext cx="4572000" cy="3566160"/>
+          </a:xfrm>
+          <a:prstGeom prst="rect">
+            <a:avLst/>
+          </a:prstGeom>
+          <a:noFill/>
+        </p:spPr>
+        <p:txBody>
+          <a:bodyPr wrap="square" lIns="0" tIns="0" rIns="0" bIns="0">
+            <a:spAutoFit/>
+          </a:bodyPr>
+          <a:lstStyle/>
+          <a:p>
+            <a:pPr>
+              <a:defRPr sz="2000" b="1">
+                <a:solidFill>
+                  <a:srgbClr val="14110D"/>
+                </a:solidFill>
+                <a:latin typeface="Segoe UI"/>
+              </a:defRPr>
+            </a:pPr>
+            <a:r>
+              <a:t>Tells You What Happened &amp; Blocks It Everywhere</a:t>
+            </a:r>
+          </a:p>
+          <a:p>
+            <a:pPr>
+              <a:spcBef>
+                <a:spcPts val="1200"/>
+              </a:spcBef>
+              <a:defRPr sz="1500" b="1">
+                <a:solidFill>
+                  <a:srgbClr val="14110D"/>
+                </a:solidFill>
+                <a:latin typeface="Segoe UI"/>
+              </a:defRPr>
+            </a:pPr>
+            <a:r>
+              <a:t>• Explains the Threat Clearly:</a:t>
+            </a:r>
+          </a:p>
+          <a:p>
+            <a:pPr>
+              <a:spcBef>
+                <a:spcPts val="200"/>
+              </a:spcBef>
+              <a:defRPr sz="1300">
+                <a:solidFill>
+                  <a:srgbClr val="555048"/>
+                </a:solidFill>
+                <a:latin typeface="Segoe UI"/>
+              </a:defRPr>
+            </a:pPr>
+            <a:r>
+              <a:t>Identifies the exact techniques the attacker used (e.g. injecting code into processes or setting up secret auto-run keys).</a:t>
+            </a:r>
+          </a:p>
+          <a:p>
+            <a:pPr>
+              <a:spcBef>
+                <a:spcPts val="1200"/>
+              </a:spcBef>
+              <a:defRPr sz="1500" b="1">
+                <a:solidFill>
+                  <a:srgbClr val="14110D"/>
+                </a:solidFill>
+                <a:latin typeface="Segoe UI"/>
+              </a:defRPr>
+            </a:pPr>
+            <a:r>
+              <a:t>• Maps to MITRE ATT&amp;CK:</a:t>
+            </a:r>
+          </a:p>
+          <a:p>
+            <a:pPr>
+              <a:spcBef>
+                <a:spcPts val="200"/>
+              </a:spcBef>
+              <a:defRPr sz="1300">
+                <a:solidFill>
+                  <a:srgbClr val="555048"/>
+                </a:solidFill>
+                <a:latin typeface="Segoe UI"/>
+              </a:defRPr>
+            </a:pPr>
+            <a:r>
+              <a:t>Industry-standard tagging (T1055, T1547) so security teams understand the risk instantly.</a:t>
+            </a:r>
+          </a:p>
+          <a:p>
+            <a:pPr>
+              <a:spcBef>
+                <a:spcPts val="1200"/>
+              </a:spcBef>
+              <a:defRPr sz="1500" b="1">
+                <a:solidFill>
+                  <a:srgbClr val="14110D"/>
+                </a:solidFill>
+                <a:latin typeface="Segoe UI"/>
+              </a:defRPr>
+            </a:pPr>
+            <a:r>
+              <a:t>• Writes the Defense Rule:</a:t>
+            </a:r>
+          </a:p>
+          <a:p>
+            <a:pPr>
+              <a:spcBef>
+                <a:spcPts val="200"/>
+              </a:spcBef>
+              <a:defRPr sz="1300">
+                <a:solidFill>
+                  <a:srgbClr val="555048"/>
+                </a:solidFill>
+                <a:latin typeface="Segoe UI"/>
+              </a:defRPr>
+            </a:pPr>
+            <a:r>
+              <a:t>Generates a complete, ready-to-use YARA rule that your firewalls, EDR, and mail filters can apply right away.</a:t>
             </a:r>
           </a:p>
         </p:txBody>

</xml_diff>